<commit_message>
fix: pptx DAIR-sessie 2 weer gelijk aan spec
De vorige commit bevatte een pptx die PowerPoint over de build heen had
opgeslagen, met de oude feedbackslide. Neemt de tekstwijzigingen uit
PowerPoint over in de spec (teamslide, definities, dashboard-footer).

Co-Authored-By: Claude Opus 5.5 (1M context) <noreply@anthropic.com>
</commit_message>
<xml_diff>
--- a/exports/261029_dair_onderwijsdata/261029_dair_onderwijsdata.pptx
+++ b/exports/261029_dair_onderwijsdata/261029_dair_onderwijsdata.pptx
@@ -24339,7 +24339,29 @@
                 <a:ea typeface="General Sans Semibold" pitchFamily="34" charset="-122"/>
                 <a:cs typeface="General Sans Semibold" pitchFamily="34" charset="-120"/>
               </a:rPr>
-              <a:t>Spiegelmoment 2: is het te vertrouwen?</a:t>
+              <a:t>Spiegelmoment 2: is het rapport </a:t>
+            </a:r>
+            <a:r>
+              <a:rPr lang="en-US" sz="4800" dirty="0" err="1">
+                <a:solidFill>
+                  <a:srgbClr val="000000"/>
+                </a:solidFill>
+                <a:latin typeface="General Sans Semibold" pitchFamily="34" charset="0"/>
+                <a:ea typeface="General Sans Semibold" pitchFamily="34" charset="-122"/>
+                <a:cs typeface="General Sans Semibold" pitchFamily="34" charset="-120"/>
+              </a:rPr>
+              <a:t>compleet</a:t>
+            </a:r>
+            <a:r>
+              <a:rPr lang="en-US" sz="4800" dirty="0">
+                <a:solidFill>
+                  <a:srgbClr val="000000"/>
+                </a:solidFill>
+                <a:latin typeface="General Sans Semibold" pitchFamily="34" charset="0"/>
+                <a:ea typeface="General Sans Semibold" pitchFamily="34" charset="-122"/>
+                <a:cs typeface="General Sans Semibold" pitchFamily="34" charset="-120"/>
+              </a:rPr>
+              <a:t>?</a:t>
             </a:r>
             <a:endParaRPr lang="en-US" sz="4800" dirty="0"/>
           </a:p>
@@ -24381,7 +24403,117 @@
                 <a:ea typeface="Cooper Lt BT" pitchFamily="34" charset="-122"/>
                 <a:cs typeface="Cooper Lt BT" pitchFamily="34" charset="-120"/>
               </a:rPr>
-              <a:t>Wat klopte, wat niet, en waaraan zag je dat? Eerst aan tafel.</a:t>
+              <a:t>Wat mis je, wat </a:t>
+            </a:r>
+            <a:r>
+              <a:rPr lang="en-US" sz="2200" dirty="0" err="1">
+                <a:solidFill>
+                  <a:srgbClr val="000000"/>
+                </a:solidFill>
+                <a:latin typeface="Cooper Lt BT" pitchFamily="34" charset="0"/>
+                <a:ea typeface="Cooper Lt BT" pitchFamily="34" charset="-122"/>
+                <a:cs typeface="Cooper Lt BT" pitchFamily="34" charset="-120"/>
+              </a:rPr>
+              <a:t>kan</a:t>
+            </a:r>
+            <a:r>
+              <a:rPr lang="en-US" sz="2200" dirty="0">
+                <a:solidFill>
+                  <a:srgbClr val="000000"/>
+                </a:solidFill>
+                <a:latin typeface="Cooper Lt BT" pitchFamily="34" charset="0"/>
+                <a:ea typeface="Cooper Lt BT" pitchFamily="34" charset="-122"/>
+                <a:cs typeface="Cooper Lt BT" pitchFamily="34" charset="-120"/>
+              </a:rPr>
+              <a:t> </a:t>
+            </a:r>
+            <a:r>
+              <a:rPr lang="en-US" sz="2200" dirty="0" err="1">
+                <a:solidFill>
+                  <a:srgbClr val="000000"/>
+                </a:solidFill>
+                <a:latin typeface="Cooper Lt BT" pitchFamily="34" charset="0"/>
+                <a:ea typeface="Cooper Lt BT" pitchFamily="34" charset="-122"/>
+                <a:cs typeface="Cooper Lt BT" pitchFamily="34" charset="-120"/>
+              </a:rPr>
+              <a:t>beter</a:t>
+            </a:r>
+            <a:r>
+              <a:rPr lang="en-US" sz="2200" dirty="0">
+                <a:solidFill>
+                  <a:srgbClr val="000000"/>
+                </a:solidFill>
+                <a:latin typeface="Cooper Lt BT" pitchFamily="34" charset="0"/>
+                <a:ea typeface="Cooper Lt BT" pitchFamily="34" charset="-122"/>
+                <a:cs typeface="Cooper Lt BT" pitchFamily="34" charset="-120"/>
+              </a:rPr>
+              <a:t>? Zou je het </a:t>
+            </a:r>
+            <a:r>
+              <a:rPr lang="en-US" sz="2200" dirty="0" err="1">
+                <a:solidFill>
+                  <a:srgbClr val="000000"/>
+                </a:solidFill>
+                <a:latin typeface="Cooper Lt BT" pitchFamily="34" charset="0"/>
+                <a:ea typeface="Cooper Lt BT" pitchFamily="34" charset="-122"/>
+                <a:cs typeface="Cooper Lt BT" pitchFamily="34" charset="-120"/>
+              </a:rPr>
+              <a:t>doorsturen</a:t>
+            </a:r>
+            <a:r>
+              <a:rPr lang="en-US" sz="2200" dirty="0">
+                <a:solidFill>
+                  <a:srgbClr val="000000"/>
+                </a:solidFill>
+                <a:latin typeface="Cooper Lt BT" pitchFamily="34" charset="0"/>
+                <a:ea typeface="Cooper Lt BT" pitchFamily="34" charset="-122"/>
+                <a:cs typeface="Cooper Lt BT" pitchFamily="34" charset="-120"/>
+              </a:rPr>
+              <a:t> </a:t>
+            </a:r>
+            <a:r>
+              <a:rPr lang="en-US" sz="2200" dirty="0" err="1">
+                <a:solidFill>
+                  <a:srgbClr val="000000"/>
+                </a:solidFill>
+                <a:latin typeface="Cooper Lt BT" pitchFamily="34" charset="0"/>
+                <a:ea typeface="Cooper Lt BT" pitchFamily="34" charset="-122"/>
+                <a:cs typeface="Cooper Lt BT" pitchFamily="34" charset="-120"/>
+              </a:rPr>
+              <a:t>aan</a:t>
+            </a:r>
+            <a:r>
+              <a:rPr lang="en-US" sz="2200" dirty="0">
+                <a:solidFill>
+                  <a:srgbClr val="000000"/>
+                </a:solidFill>
+                <a:latin typeface="Cooper Lt BT" pitchFamily="34" charset="0"/>
+                <a:ea typeface="Cooper Lt BT" pitchFamily="34" charset="-122"/>
+                <a:cs typeface="Cooper Lt BT" pitchFamily="34" charset="-120"/>
+              </a:rPr>
+              <a:t> </a:t>
+            </a:r>
+            <a:r>
+              <a:rPr lang="en-US" sz="2200" dirty="0" err="1">
+                <a:solidFill>
+                  <a:srgbClr val="000000"/>
+                </a:solidFill>
+                <a:latin typeface="Cooper Lt BT" pitchFamily="34" charset="0"/>
+                <a:ea typeface="Cooper Lt BT" pitchFamily="34" charset="-122"/>
+                <a:cs typeface="Cooper Lt BT" pitchFamily="34" charset="-120"/>
+              </a:rPr>
+              <a:t>collega</a:t>
+            </a:r>
+            <a:r>
+              <a:rPr lang="en-US" sz="2200" dirty="0">
+                <a:solidFill>
+                  <a:srgbClr val="000000"/>
+                </a:solidFill>
+                <a:latin typeface="Cooper Lt BT" pitchFamily="34" charset="0"/>
+                <a:ea typeface="Cooper Lt BT" pitchFamily="34" charset="-122"/>
+                <a:cs typeface="Cooper Lt BT" pitchFamily="34" charset="-120"/>
+              </a:rPr>
+              <a:t>?</a:t>
             </a:r>
             <a:endParaRPr lang="en-US" sz="2200" dirty="0"/>
           </a:p>
@@ -29656,7 +29788,7 @@
         <p:spPr>
           <a:xfrm>
             <a:off x="548640" y="4267962"/>
-            <a:ext cx="11094415" cy="457200"/>
+            <a:ext cx="11207669" cy="457200"/>
           </a:xfrm>
           <a:prstGeom prst="rect">
             <a:avLst/>
@@ -29668,11 +29800,10 @@
           <a:bodyPr wrap="square" lIns="0" tIns="0" rIns="0" bIns="0" rtlCol="0" anchor="t"/>
           <a:lstStyle/>
           <a:p>
-            <a:pPr marL="0" indent="0" algn="l">
+            <a:pPr>
               <a:lnSpc>
                 <a:spcPct val="105000"/>
               </a:lnSpc>
-              <a:buNone/>
             </a:pPr>
             <a:r>
               <a:rPr lang="en-US" sz="1800" dirty="0" err="1">
@@ -29760,18 +29891,21 @@
                 <a:ea typeface="General Sans Semibold" pitchFamily="34" charset="-122"/>
                 <a:cs typeface="General Sans Semibold" pitchFamily="34" charset="-120"/>
               </a:rPr>
-              <a:t>. </a:t>
+              <a:t>. 		</a:t>
             </a:r>
-          </a:p>
-          <a:p>
-            <a:pPr marL="0" indent="0" algn="r">
-              <a:lnSpc>
-                <a:spcPct val="105000"/>
-              </a:lnSpc>
-              <a:buNone/>
-            </a:pPr>
             <a:r>
-              <a:rPr lang="en-US" sz="1800" dirty="0" err="1">
+              <a:rPr lang="en-US" sz="1800">
+                <a:solidFill>
+                  <a:srgbClr val="3D68EC"/>
+                </a:solidFill>
+                <a:latin typeface="General Sans Semibold" pitchFamily="34" charset="0"/>
+                <a:ea typeface="General Sans Semibold" pitchFamily="34" charset="-122"/>
+                <a:cs typeface="General Sans Semibold" pitchFamily="34" charset="-120"/>
+              </a:rPr>
+              <a:t> </a:t>
+            </a:r>
+            <a:r>
+              <a:rPr lang="en-US">
                 <a:solidFill>
                   <a:schemeClr val="accent2"/>
                 </a:solidFill>
@@ -29779,10 +29913,10 @@
                 <a:ea typeface="General Sans Semibold" pitchFamily="34" charset="-122"/>
                 <a:cs typeface="General Sans Semibold" pitchFamily="34" charset="-120"/>
               </a:rPr>
-              <a:t>Niet</a:t>
+              <a:t>Maar </a:t>
             </a:r>
             <a:r>
-              <a:rPr lang="en-US" sz="1800" dirty="0">
+              <a:rPr lang="en-US" dirty="0" err="1">
                 <a:solidFill>
                   <a:schemeClr val="accent2"/>
                 </a:solidFill>
@@ -29790,10 +29924,65 @@
                 <a:ea typeface="General Sans Semibold" pitchFamily="34" charset="-122"/>
                 <a:cs typeface="General Sans Semibold" pitchFamily="34" charset="-120"/>
               </a:rPr>
-              <a:t> elke vraag </a:t>
+              <a:t>niet</a:t>
             </a:r>
             <a:r>
-              <a:rPr lang="en-US" sz="1800" dirty="0" err="1">
+              <a:rPr lang="en-US" dirty="0">
+                <a:solidFill>
+                  <a:schemeClr val="accent2"/>
+                </a:solidFill>
+                <a:latin typeface="General Sans Semibold" pitchFamily="34" charset="0"/>
+                <a:ea typeface="General Sans Semibold" pitchFamily="34" charset="-122"/>
+                <a:cs typeface="General Sans Semibold" pitchFamily="34" charset="-120"/>
+              </a:rPr>
+              <a:t> </a:t>
+            </a:r>
+            <a:r>
+              <a:rPr lang="en-US" dirty="0" err="1">
+                <a:solidFill>
+                  <a:schemeClr val="accent2"/>
+                </a:solidFill>
+                <a:latin typeface="General Sans Semibold" pitchFamily="34" charset="0"/>
+                <a:ea typeface="General Sans Semibold" pitchFamily="34" charset="-122"/>
+                <a:cs typeface="General Sans Semibold" pitchFamily="34" charset="-120"/>
+              </a:rPr>
+              <a:t>elke</a:t>
+            </a:r>
+            <a:r>
+              <a:rPr lang="en-US" dirty="0">
+                <a:solidFill>
+                  <a:schemeClr val="accent2"/>
+                </a:solidFill>
+                <a:latin typeface="General Sans Semibold" pitchFamily="34" charset="0"/>
+                <a:ea typeface="General Sans Semibold" pitchFamily="34" charset="-122"/>
+                <a:cs typeface="General Sans Semibold" pitchFamily="34" charset="-120"/>
+              </a:rPr>
+              <a:t> </a:t>
+            </a:r>
+            <a:r>
+              <a:rPr lang="en-US" dirty="0" err="1">
+                <a:solidFill>
+                  <a:schemeClr val="accent2"/>
+                </a:solidFill>
+                <a:latin typeface="General Sans Semibold" pitchFamily="34" charset="0"/>
+                <a:ea typeface="General Sans Semibold" pitchFamily="34" charset="-122"/>
+                <a:cs typeface="General Sans Semibold" pitchFamily="34" charset="-120"/>
+              </a:rPr>
+              <a:t>vraag</a:t>
+            </a:r>
+            <a:r>
+              <a:rPr lang="en-US" dirty="0">
+                <a:solidFill>
+                  <a:schemeClr val="accent2"/>
+                </a:solidFill>
+                <a:latin typeface="General Sans Semibold" pitchFamily="34" charset="0"/>
+                <a:ea typeface="General Sans Semibold" pitchFamily="34" charset="-122"/>
+                <a:cs typeface="General Sans Semibold" pitchFamily="34" charset="-120"/>
+              </a:rPr>
+              <a:t> </a:t>
+            </a:r>
+            <a:r>
+              <a:rPr lang="en-US" dirty="0" err="1">
                 <a:solidFill>
                   <a:schemeClr val="accent2"/>
                 </a:solidFill>
@@ -29804,7 +29993,7 @@
               <a:t>wordt</a:t>
             </a:r>
             <a:r>
-              <a:rPr lang="en-US" sz="1800" dirty="0">
+              <a:rPr lang="en-US" dirty="0">
                 <a:solidFill>
                   <a:schemeClr val="accent2"/>
                 </a:solidFill>
@@ -29815,7 +30004,7 @@
               <a:t> </a:t>
             </a:r>
             <a:r>
-              <a:rPr lang="en-US" sz="1800" dirty="0" err="1">
+              <a:rPr lang="en-US" dirty="0" err="1">
                 <a:solidFill>
                   <a:schemeClr val="accent2"/>
                 </a:solidFill>
@@ -29826,7 +30015,7 @@
               <a:t>een</a:t>
             </a:r>
             <a:r>
-              <a:rPr lang="en-US" sz="1800" dirty="0">
+              <a:rPr lang="en-US" dirty="0">
                 <a:solidFill>
                   <a:schemeClr val="accent2"/>
                 </a:solidFill>
@@ -29837,7 +30026,7 @@
               <a:t> tab in </a:t>
             </a:r>
             <a:r>
-              <a:rPr lang="en-US" sz="1800" dirty="0" err="1">
+              <a:rPr lang="en-US" dirty="0" err="1">
                 <a:solidFill>
                   <a:schemeClr val="accent2"/>
                 </a:solidFill>
@@ -29848,6 +30037,33 @@
               <a:t>een</a:t>
             </a:r>
             <a:r>
+              <a:rPr lang="en-US" dirty="0">
+                <a:solidFill>
+                  <a:schemeClr val="accent2"/>
+                </a:solidFill>
+                <a:latin typeface="General Sans Semibold" pitchFamily="34" charset="0"/>
+                <a:ea typeface="General Sans Semibold" pitchFamily="34" charset="-122"/>
+                <a:cs typeface="General Sans Semibold" pitchFamily="34" charset="-120"/>
+              </a:rPr>
+              <a:t> dashboard</a:t>
+            </a:r>
+            <a:endParaRPr lang="en-US" sz="1800" dirty="0">
+              <a:solidFill>
+                <a:srgbClr val="3D68EC"/>
+              </a:solidFill>
+              <a:latin typeface="General Sans Semibold" pitchFamily="34" charset="0"/>
+              <a:ea typeface="General Sans Semibold" pitchFamily="34" charset="-122"/>
+              <a:cs typeface="General Sans Semibold" pitchFamily="34" charset="-120"/>
+            </a:endParaRPr>
+          </a:p>
+          <a:p>
+            <a:pPr marL="0" indent="0" algn="r">
+              <a:lnSpc>
+                <a:spcPct val="105000"/>
+              </a:lnSpc>
+              <a:buNone/>
+            </a:pPr>
+            <a:r>
               <a:rPr lang="en-US" sz="1800" dirty="0">
                 <a:solidFill>
                   <a:schemeClr val="accent2"/>
@@ -29856,7 +30072,7 @@
                 <a:ea typeface="General Sans Semibold" pitchFamily="34" charset="-122"/>
                 <a:cs typeface="General Sans Semibold" pitchFamily="34" charset="-120"/>
               </a:rPr>
-              <a:t> dashboard.</a:t>
+              <a:t>.</a:t>
             </a:r>
             <a:r>
               <a:rPr lang="en-US" sz="1800" dirty="0">

</xml_diff>

<commit_message>
fix: Npuls-fonts embedden in de pptx van DAIR-sessie 2
PowerPoint in de browser gebruikt nooit lokaal geïnstalleerde fonts en
pc's zonder General Sans/Cooper Lt BT vallen terug op Calibri en Cooper
Black. powerclaude embedt de fonts nu via pptx-embed-fonts; deze
devDependency is daarvoor nodig. Deck opnieuw gebouwd, tekst ongewijzigd.

Co-Authored-By: Claude Opus 5.5 <noreply@anthropic.com>
</commit_message>
<xml_diff>
--- a/exports/261029_dair_onderwijsdata/261029_dair_onderwijsdata.pptx
+++ b/exports/261029_dair_onderwijsdata/261029_dair_onderwijsdata.pptx
@@ -1,6 +1,6 @@
 
 <file path=ppt/presentation.xml><?xml version="1.0" encoding="utf-8"?>
-<p:presentation xmlns:a="http://schemas.openxmlformats.org/drawingml/2006/main" xmlns:r="http://schemas.openxmlformats.org/officeDocument/2006/relationships" xmlns:p="http://schemas.openxmlformats.org/presentationml/2006/main" saveSubsetFonts="1" autoCompressPictures="0">
+<p:presentation xmlns:a="http://schemas.openxmlformats.org/drawingml/2006/main" xmlns:r="http://schemas.openxmlformats.org/officeDocument/2006/relationships" xmlns:p="http://schemas.openxmlformats.org/presentationml/2006/main" saveSubsetFonts="true" autoCompressPictures="0" embedTrueTypeFonts="true">
   <p:sldMasterIdLst>
     <p:sldMasterId id="2147483648" r:id="rId1"/>
   </p:sldMasterIdLst>
@@ -34,6 +34,20 @@
   </p:notesMasterIdLst>
   <p:sldSz cx="12192000" cy="6858000"/>
   <p:notesSz cx="6858000" cy="12192000"/>
+  <p:embeddedFontLst>
+    <p:embeddedFont>
+      <p:font typeface="General Sans"/>
+      <p:regular r:id="rId201314"/>
+    </p:embeddedFont>
+    <p:embeddedFont>
+      <p:font typeface="General Sans Semibold"/>
+      <p:regular r:id="rId201315"/>
+    </p:embeddedFont>
+    <p:embeddedFont>
+      <p:font typeface="Cooper Lt BT"/>
+      <p:regular r:id="rId201316"/>
+    </p:embeddedFont>
+  </p:embeddedFontLst>
   <p:defaultTextStyle>
     <a:lvl1pPr marL="0" algn="l" defTabSz="914400" rtl="0" eaLnBrk="1" latinLnBrk="0" hangingPunct="1">
       <a:defRPr sz="1800" kern="1200">

</xml_diff>